<commit_message>
Update weekly digest - 2025-12-14
</commit_message>
<xml_diff>
--- a/AI_Weekly_2025-12-14.pptx
+++ b/AI_Weekly_2025-12-14.pptx
@@ -3154,6 +3154,37 @@
           </a:p>
         </p:txBody>
       </p:sp>
+      <p:sp>
+        <p:nvSpPr>
+          <p:cNvPr id="4" name="TextBox 3"/>
+          <p:cNvSpPr txBox="1"/>
+          <p:nvPr/>
+        </p:nvSpPr>
+        <p:spPr>
+          <a:xfrm>
+            <a:off x="457200" y="6400800"/>
+            <a:ext cx="7315200" cy="274320"/>
+          </a:xfrm>
+          <a:prstGeom prst="rect">
+            <a:avLst/>
+          </a:prstGeom>
+          <a:noFill/>
+        </p:spPr>
+        <p:txBody>
+          <a:bodyPr wrap="none">
+            <a:spAutoFit/>
+          </a:bodyPr>
+          <a:lstStyle/>
+          <a:p>
+            <a:pPr algn="ctr">
+              <a:defRPr sz="1000"/>
+            </a:pPr>
+            <a:r>
+              <a:t>Slide 1</a:t>
+            </a:r>
+          </a:p>
+        </p:txBody>
+      </p:sp>
     </p:spTree>
   </p:cSld>
   <p:clrMapOvr>
@@ -3188,7 +3219,7 @@
           <a:lstStyle/>
           <a:p>
             <a:r>
-              <a:t>1. OpenAI are quietly adopting skills, now available in ChatGPT and Codex CLI</a:t>
+              <a:t>1. OpenAI are quietly adopting skills, now available in ChatGPT and Co...</a:t>
             </a:r>
           </a:p>
         </p:txBody>
@@ -3209,25 +3240,63 @@
           <a:lstStyle/>
           <a:p>
             <a:r>
-              <a:t>OpenAI is rolling out 'skills' functionality that enables more sophisticated agent capabilities for tool use and task execution in ChatGPT.</a:t>
-            </a:r>
-          </a:p>
-          <a:p>
-            <a:pPr/>
-          </a:p>
-          <a:p>
-            <a:pPr/>
-            <a:r>
-              <a:t>📎 Hacker News • 558 points • 312 comments</a:t>
-            </a:r>
-          </a:p>
-          <a:p>
-            <a:pPr/>
-          </a:p>
-          <a:p>
-            <a:pPr/>
-            <a:r>
-              <a:t>🔗 https://simonwillison.net/2025/Dec/12/openai-skills/</a:t>
+              <a:t>OpenAI introduces 'skills' capability enabling structured tool use and actions</a:t>
+            </a:r>
+          </a:p>
+          <a:p>
+            <a:r>
+              <a:t>in ChatGPT, marking a significant step toward more agentic behavior in their</a:t>
+            </a:r>
+          </a:p>
+          <a:p>
+            <a:r>
+              <a:t>flagship product.</a:t>
+            </a:r>
+          </a:p>
+          <a:p>
+            <a:pPr/>
+          </a:p>
+          <a:p>
+            <a:pPr/>
+            <a:r>
+              <a:t>Source: Hacker News • 558 points • 312 comments</a:t>
+            </a:r>
+          </a:p>
+          <a:p>
+            <a:pPr/>
+            <a:r>
+              <a:t>Link: https://simonwillison.net/2025/Dec/12/openai-sk...</a:t>
+            </a:r>
+          </a:p>
+        </p:txBody>
+      </p:sp>
+      <p:sp>
+        <p:nvSpPr>
+          <p:cNvPr id="4" name="TextBox 3"/>
+          <p:cNvSpPr txBox="1"/>
+          <p:nvPr/>
+        </p:nvSpPr>
+        <p:spPr>
+          <a:xfrm>
+            <a:off x="457200" y="6400800"/>
+            <a:ext cx="7315200" cy="274320"/>
+          </a:xfrm>
+          <a:prstGeom prst="rect">
+            <a:avLst/>
+          </a:prstGeom>
+          <a:noFill/>
+        </p:spPr>
+        <p:txBody>
+          <a:bodyPr wrap="none">
+            <a:spAutoFit/>
+          </a:bodyPr>
+          <a:lstStyle/>
+          <a:p>
+            <a:pPr algn="ctr">
+              <a:defRPr sz="1000"/>
+            </a:pPr>
+            <a:r>
+              <a:t>Slide 10</a:t>
             </a:r>
           </a:p>
         </p:txBody>
@@ -3287,25 +3356,63 @@
           <a:lstStyle/>
           <a:p>
             <a:r>
-              <a:t>Major new model release from OpenAI with implications for agent reasoning and planning capabilities.</a:t>
-            </a:r>
-          </a:p>
-          <a:p>
-            <a:pPr/>
-          </a:p>
-          <a:p>
-            <a:pPr/>
-            <a:r>
-              <a:t>📎 Hacker News • 1181 points • 1065 comments</a:t>
-            </a:r>
-          </a:p>
-          <a:p>
-            <a:pPr/>
-          </a:p>
-          <a:p>
-            <a:pPr/>
-            <a:r>
-              <a:t>🔗 https://openai.com/index/introducing-gpt-5-2/</a:t>
+              <a:t>Major model release from OpenAI with potential implications for agent</a:t>
+            </a:r>
+          </a:p>
+          <a:p>
+            <a:r>
+              <a:t>capabilities, reasoning, and planning—generating significant community</a:t>
+            </a:r>
+          </a:p>
+          <a:p>
+            <a:r>
+              <a:t>discussion.</a:t>
+            </a:r>
+          </a:p>
+          <a:p>
+            <a:pPr/>
+          </a:p>
+          <a:p>
+            <a:pPr/>
+            <a:r>
+              <a:t>Source: Hacker News • 1181 points • 1065 comments</a:t>
+            </a:r>
+          </a:p>
+          <a:p>
+            <a:pPr/>
+            <a:r>
+              <a:t>Link: https://openai.com/index/introducing-gpt-5-2/</a:t>
+            </a:r>
+          </a:p>
+        </p:txBody>
+      </p:sp>
+      <p:sp>
+        <p:nvSpPr>
+          <p:cNvPr id="4" name="TextBox 3"/>
+          <p:cNvSpPr txBox="1"/>
+          <p:nvPr/>
+        </p:nvSpPr>
+        <p:spPr>
+          <a:xfrm>
+            <a:off x="457200" y="6400800"/>
+            <a:ext cx="7315200" cy="274320"/>
+          </a:xfrm>
+          <a:prstGeom prst="rect">
+            <a:avLst/>
+          </a:prstGeom>
+          <a:noFill/>
+        </p:spPr>
+        <p:txBody>
+          <a:bodyPr wrap="none">
+            <a:spAutoFit/>
+          </a:bodyPr>
+          <a:lstStyle/>
+          <a:p>
+            <a:pPr algn="ctr">
+              <a:defRPr sz="1000"/>
+            </a:pPr>
+            <a:r>
+              <a:t>Slide 11</a:t>
             </a:r>
           </a:p>
         </p:txBody>
@@ -3365,25 +3472,63 @@
           <a:lstStyle/>
           <a:p>
             <a:r>
-              <a:t>Autonomous AI agent successfully performed complex penetration testing, demonstrating advanced planning and tool use capabilities that outperformed human professionals.</a:t>
-            </a:r>
-          </a:p>
-          <a:p>
-            <a:pPr/>
-          </a:p>
-          <a:p>
-            <a:pPr/>
-            <a:r>
-              <a:t>📎 r/artificial • 196 upvotes • 31 comments</a:t>
-            </a:r>
-          </a:p>
-          <a:p>
-            <a:pPr/>
-          </a:p>
-          <a:p>
-            <a:pPr/>
-            <a:r>
-              <a:t>🔗 https://reddit.com/r/artificial/comments/1pkuaaq/an_ai_agent</a:t>
+              <a:t>Demonstrates autonomous agent capability to perform complex, multi-step</a:t>
+            </a:r>
+          </a:p>
+          <a:p>
+            <a:r>
+              <a:t>cybersecurity operations outperforming human professionals, showing real-world</a:t>
+            </a:r>
+          </a:p>
+          <a:p>
+            <a:r>
+              <a:t>agentic task execution.</a:t>
+            </a:r>
+          </a:p>
+          <a:p>
+            <a:pPr/>
+          </a:p>
+          <a:p>
+            <a:pPr/>
+            <a:r>
+              <a:t>Source: r/artificial • 198 upvotes • 31 comments</a:t>
+            </a:r>
+          </a:p>
+          <a:p>
+            <a:pPr/>
+            <a:r>
+              <a:t>Link: https://reddit.com/r/artificial/comments/1pkuaa...</a:t>
+            </a:r>
+          </a:p>
+        </p:txBody>
+      </p:sp>
+      <p:sp>
+        <p:nvSpPr>
+          <p:cNvPr id="4" name="TextBox 3"/>
+          <p:cNvSpPr txBox="1"/>
+          <p:nvPr/>
+        </p:nvSpPr>
+        <p:spPr>
+          <a:xfrm>
+            <a:off x="457200" y="6400800"/>
+            <a:ext cx="7315200" cy="274320"/>
+          </a:xfrm>
+          <a:prstGeom prst="rect">
+            <a:avLst/>
+          </a:prstGeom>
+          <a:noFill/>
+        </p:spPr>
+        <p:txBody>
+          <a:bodyPr wrap="none">
+            <a:spAutoFit/>
+          </a:bodyPr>
+          <a:lstStyle/>
+          <a:p>
+            <a:pPr algn="ctr">
+              <a:defRPr sz="1000"/>
+            </a:pPr>
+            <a:r>
+              <a:t>Slide 12</a:t>
             </a:r>
           </a:p>
         </p:txBody>
@@ -3422,7 +3567,7 @@
           <a:lstStyle/>
           <a:p>
             <a:r>
-              <a:t>4. Pete Hegseth Says the Pentagon's New Chatbot Will Make America 'More Lethal'</a:t>
+              <a:t>4. Pete Hegseth Says the Pentagon's New Chatbot Will Make America 'Mor...</a:t>
             </a:r>
           </a:p>
         </p:txBody>
@@ -3443,25 +3588,63 @@
           <a:lstStyle/>
           <a:p>
             <a:r>
-              <a:t>Pentagon deploying Google Gemini as agentic tool directly to military personnel, representing major institutional adoption of AI agents in defense operations.</a:t>
-            </a:r>
-          </a:p>
-          <a:p>
-            <a:pPr/>
-          </a:p>
-          <a:p>
-            <a:pPr/>
-            <a:r>
-              <a:t>📎 r/artificial • 254 upvotes • 122 comments</a:t>
-            </a:r>
-          </a:p>
-          <a:p>
-            <a:pPr/>
-          </a:p>
-          <a:p>
-            <a:pPr/>
-            <a:r>
-              <a:t>🔗 https://reddit.com/r/artificial/comments/1piors1/pete_hegset</a:t>
+              <a:t>Major deployment of AI agents in military operations, representing significant</a:t>
+            </a:r>
+          </a:p>
+          <a:p>
+            <a:r>
+              <a:t>real-world application of agentic systems in high-stakes decision-making</a:t>
+            </a:r>
+          </a:p>
+          <a:p>
+            <a:r>
+              <a:t>environments.</a:t>
+            </a:r>
+          </a:p>
+          <a:p>
+            <a:pPr/>
+          </a:p>
+          <a:p>
+            <a:pPr/>
+            <a:r>
+              <a:t>Source: r/artificial • 256 upvotes • 122 comments</a:t>
+            </a:r>
+          </a:p>
+          <a:p>
+            <a:pPr/>
+            <a:r>
+              <a:t>Link: https://reddit.com/r/artificial/comments/1piors...</a:t>
+            </a:r>
+          </a:p>
+        </p:txBody>
+      </p:sp>
+      <p:sp>
+        <p:nvSpPr>
+          <p:cNvPr id="4" name="TextBox 3"/>
+          <p:cNvSpPr txBox="1"/>
+          <p:nvPr/>
+        </p:nvSpPr>
+        <p:spPr>
+          <a:xfrm>
+            <a:off x="457200" y="6400800"/>
+            <a:ext cx="7315200" cy="274320"/>
+          </a:xfrm>
+          <a:prstGeom prst="rect">
+            <a:avLst/>
+          </a:prstGeom>
+          <a:noFill/>
+        </p:spPr>
+        <p:txBody>
+          <a:bodyPr wrap="none">
+            <a:spAutoFit/>
+          </a:bodyPr>
+          <a:lstStyle/>
+          <a:p>
+            <a:pPr algn="ctr">
+              <a:defRPr sz="1000"/>
+            </a:pPr>
+            <a:r>
+              <a:t>Slide 13</a:t>
             </a:r>
           </a:p>
         </p:txBody>
@@ -3521,25 +3704,58 @@
           <a:lstStyle/>
           <a:p>
             <a:r>
-              <a:t>Strategic shift from Meta could impact availability of open-source agent frameworks and models, affecting the broader agentic AI ecosystem.</a:t>
-            </a:r>
-          </a:p>
-          <a:p>
-            <a:pPr/>
-          </a:p>
-          <a:p>
-            <a:pPr/>
-            <a:r>
-              <a:t>📎 r/artificial • 151 upvotes • 57 comments</a:t>
-            </a:r>
-          </a:p>
-          <a:p>
-            <a:pPr/>
-          </a:p>
-          <a:p>
-            <a:pPr/>
-            <a:r>
-              <a:t>🔗 https://reddit.com/r/artificial/comments/1plnzz7/meta_is_piv</a:t>
+              <a:t>Strategic shift at Meta could impact availability of open-source agent</a:t>
+            </a:r>
+          </a:p>
+          <a:p>
+            <a:r>
+              <a:t>frameworks and models, affecting the broader agentic AI ecosystem.</a:t>
+            </a:r>
+          </a:p>
+          <a:p>
+            <a:pPr/>
+          </a:p>
+          <a:p>
+            <a:pPr/>
+            <a:r>
+              <a:t>Source: r/artificial • 149 upvotes • 57 comments</a:t>
+            </a:r>
+          </a:p>
+          <a:p>
+            <a:pPr/>
+            <a:r>
+              <a:t>Link: https://reddit.com/r/artificial/comments/1plnzz...</a:t>
+            </a:r>
+          </a:p>
+        </p:txBody>
+      </p:sp>
+      <p:sp>
+        <p:nvSpPr>
+          <p:cNvPr id="4" name="TextBox 3"/>
+          <p:cNvSpPr txBox="1"/>
+          <p:nvPr/>
+        </p:nvSpPr>
+        <p:spPr>
+          <a:xfrm>
+            <a:off x="457200" y="6400800"/>
+            <a:ext cx="7315200" cy="274320"/>
+          </a:xfrm>
+          <a:prstGeom prst="rect">
+            <a:avLst/>
+          </a:prstGeom>
+          <a:noFill/>
+        </p:spPr>
+        <p:txBody>
+          <a:bodyPr wrap="none">
+            <a:spAutoFit/>
+          </a:bodyPr>
+          <a:lstStyle/>
+          <a:p>
+            <a:pPr algn="ctr">
+              <a:defRPr sz="1000"/>
+            </a:pPr>
+            <a:r>
+              <a:t>Slide 14</a:t>
             </a:r>
           </a:p>
         </p:txBody>
@@ -3602,6 +3818,46 @@
               <a:t>4 key updates</a:t>
             </a:r>
           </a:p>
+          <a:p>
+            <a:pPr/>
+          </a:p>
+          <a:p>
+            <a:pPr/>
+            <a:r>
+              <a:t>Swipe to explore →</a:t>
+            </a:r>
+          </a:p>
+        </p:txBody>
+      </p:sp>
+      <p:sp>
+        <p:nvSpPr>
+          <p:cNvPr id="4" name="TextBox 3"/>
+          <p:cNvSpPr txBox="1"/>
+          <p:nvPr/>
+        </p:nvSpPr>
+        <p:spPr>
+          <a:xfrm>
+            <a:off x="457200" y="6400800"/>
+            <a:ext cx="7315200" cy="274320"/>
+          </a:xfrm>
+          <a:prstGeom prst="rect">
+            <a:avLst/>
+          </a:prstGeom>
+          <a:noFill/>
+        </p:spPr>
+        <p:txBody>
+          <a:bodyPr wrap="none">
+            <a:spAutoFit/>
+          </a:bodyPr>
+          <a:lstStyle/>
+          <a:p>
+            <a:pPr algn="ctr">
+              <a:defRPr sz="1000"/>
+            </a:pPr>
+            <a:r>
+              <a:t>Slide 15</a:t>
+            </a:r>
+          </a:p>
         </p:txBody>
       </p:sp>
     </p:spTree>
@@ -3659,25 +3915,58 @@
           <a:lstStyle/>
           <a:p>
             <a:r>
-              <a:t>New CLI tool from Mistral AI enabling developer-focused agentic workflows with improved code understanding and execution capabilities.</a:t>
-            </a:r>
-          </a:p>
-          <a:p>
-            <a:pPr/>
-          </a:p>
-          <a:p>
-            <a:pPr/>
-            <a:r>
-              <a:t>📎 r/LocalLLaMA • 686 upvotes • 218 comments</a:t>
-            </a:r>
-          </a:p>
-          <a:p>
-            <a:pPr/>
-          </a:p>
-          <a:p>
-            <a:pPr/>
-            <a:r>
-              <a:t>🔗 https://reddit.com/r/LocalLLaMA/comments/1pi9q3t/introducing</a:t>
+              <a:t>New CLI tool from Mistral enabling agentic code generation and development</a:t>
+            </a:r>
+          </a:p>
+          <a:p>
+            <a:r>
+              <a:t>workflows, expanding the ecosystem of agent-oriented developer tools.</a:t>
+            </a:r>
+          </a:p>
+          <a:p>
+            <a:pPr/>
+          </a:p>
+          <a:p>
+            <a:pPr/>
+            <a:r>
+              <a:t>Source: r/LocalLLaMA • 690 upvotes • 218 comments</a:t>
+            </a:r>
+          </a:p>
+          <a:p>
+            <a:pPr/>
+            <a:r>
+              <a:t>Link: https://reddit.com/r/LocalLLaMA/comments/1pi9q3...</a:t>
+            </a:r>
+          </a:p>
+        </p:txBody>
+      </p:sp>
+      <p:sp>
+        <p:nvSpPr>
+          <p:cNvPr id="4" name="TextBox 3"/>
+          <p:cNvSpPr txBox="1"/>
+          <p:nvPr/>
+        </p:nvSpPr>
+        <p:spPr>
+          <a:xfrm>
+            <a:off x="457200" y="6400800"/>
+            <a:ext cx="7315200" cy="274320"/>
+          </a:xfrm>
+          <a:prstGeom prst="rect">
+            <a:avLst/>
+          </a:prstGeom>
+          <a:noFill/>
+        </p:spPr>
+        <p:txBody>
+          <a:bodyPr wrap="none">
+            <a:spAutoFit/>
+          </a:bodyPr>
+          <a:lstStyle/>
+          <a:p>
+            <a:pPr algn="ctr">
+              <a:defRPr sz="1000"/>
+            </a:pPr>
+            <a:r>
+              <a:t>Slide 16</a:t>
             </a:r>
           </a:p>
         </p:txBody>
@@ -3737,25 +4026,58 @@
           <a:lstStyle/>
           <a:p>
             <a:r>
-              <a:t>Breakthrough in memory-efficient training enables development of local agent models on consumer hardware, democratizing agentic AI development.</a:t>
-            </a:r>
-          </a:p>
-          <a:p>
-            <a:pPr/>
-          </a:p>
-          <a:p>
-            <a:pPr/>
-            <a:r>
-              <a:t>📎 r/LocalLLaMA • 1018 upvotes • 114 comments</a:t>
-            </a:r>
-          </a:p>
-          <a:p>
-            <a:pPr/>
-          </a:p>
-          <a:p>
-            <a:pPr/>
-            <a:r>
-              <a:t>🔗 https://reddit.com/r/LocalLLaMA/comments/1pj51tu/you_can_now</a:t>
+              <a:t>Breakthrough in training efficiency enabling more accessible development of</a:t>
+            </a:r>
+          </a:p>
+          <a:p>
+            <a:r>
+              <a:t>custom agent models on consumer hardware, democratizing agent development.</a:t>
+            </a:r>
+          </a:p>
+          <a:p>
+            <a:pPr/>
+          </a:p>
+          <a:p>
+            <a:pPr/>
+            <a:r>
+              <a:t>Source: r/LocalLLaMA • 1021 upvotes • 114 comments</a:t>
+            </a:r>
+          </a:p>
+          <a:p>
+            <a:pPr/>
+            <a:r>
+              <a:t>Link: https://reddit.com/r/LocalLLaMA/comments/1pj51t...</a:t>
+            </a:r>
+          </a:p>
+        </p:txBody>
+      </p:sp>
+      <p:sp>
+        <p:nvSpPr>
+          <p:cNvPr id="4" name="TextBox 3"/>
+          <p:cNvSpPr txBox="1"/>
+          <p:nvPr/>
+        </p:nvSpPr>
+        <p:spPr>
+          <a:xfrm>
+            <a:off x="457200" y="6400800"/>
+            <a:ext cx="7315200" cy="274320"/>
+          </a:xfrm>
+          <a:prstGeom prst="rect">
+            <a:avLst/>
+          </a:prstGeom>
+          <a:noFill/>
+        </p:spPr>
+        <p:txBody>
+          <a:bodyPr wrap="none">
+            <a:spAutoFit/>
+          </a:bodyPr>
+          <a:lstStyle/>
+          <a:p>
+            <a:pPr algn="ctr">
+              <a:defRPr sz="1000"/>
+            </a:pPr>
+            <a:r>
+              <a:t>Slide 17</a:t>
             </a:r>
           </a:p>
         </p:txBody>
@@ -3794,7 +4116,7 @@
           <a:lstStyle/>
           <a:p>
             <a:r>
-              <a:t>3. Decoupled Q-Chunking</a:t>
+              <a:t>3. ImplicitRDP: An End-to-End Visual-Force Diffusion Policy with Struc...</a:t>
             </a:r>
           </a:p>
         </p:txBody>
@@ -3815,25 +4137,63 @@
           <a:lstStyle/>
           <a:p>
             <a:r>
-              <a:t>Novel temporal-difference method that addresses bootstrapping bias in RL agents, improving learning stability for autonomous decision-making systems.</a:t>
-            </a:r>
-          </a:p>
-          <a:p>
-            <a:pPr/>
-          </a:p>
-          <a:p>
-            <a:pPr/>
-            <a:r>
-              <a:t>📎 arXiv • Qiyang Li, Seohong Park, Sergey Levine</a:t>
-            </a:r>
-          </a:p>
-          <a:p>
-            <a:pPr/>
-          </a:p>
-          <a:p>
-            <a:pPr/>
-            <a:r>
-              <a:t>🔗 https://arxiv.org/abs/2512.10926v1</a:t>
+              <a:t>Novel end-to-end policy framework combining vision and force sensing for</a:t>
+            </a:r>
+          </a:p>
+          <a:p>
+            <a:r>
+              <a:t>robotic agents, advancing multi-modal perception for autonomous manipulation</a:t>
+            </a:r>
+          </a:p>
+          <a:p>
+            <a:r>
+              <a:t>tasks.</a:t>
+            </a:r>
+          </a:p>
+          <a:p>
+            <a:pPr/>
+          </a:p>
+          <a:p>
+            <a:pPr/>
+            <a:r>
+              <a:t>Source: arXiv • Wendi Chen, Han Xue, Yi Wang</a:t>
+            </a:r>
+          </a:p>
+          <a:p>
+            <a:pPr/>
+            <a:r>
+              <a:t>Link: https://arxiv.org/abs/2512.10946v1</a:t>
+            </a:r>
+          </a:p>
+        </p:txBody>
+      </p:sp>
+      <p:sp>
+        <p:nvSpPr>
+          <p:cNvPr id="4" name="TextBox 3"/>
+          <p:cNvSpPr txBox="1"/>
+          <p:nvPr/>
+        </p:nvSpPr>
+        <p:spPr>
+          <a:xfrm>
+            <a:off x="457200" y="6400800"/>
+            <a:ext cx="7315200" cy="274320"/>
+          </a:xfrm>
+          <a:prstGeom prst="rect">
+            <a:avLst/>
+          </a:prstGeom>
+          <a:noFill/>
+        </p:spPr>
+        <p:txBody>
+          <a:bodyPr wrap="none">
+            <a:spAutoFit/>
+          </a:bodyPr>
+          <a:lstStyle/>
+          <a:p>
+            <a:pPr algn="ctr">
+              <a:defRPr sz="1000"/>
+            </a:pPr>
+            <a:r>
+              <a:t>Slide 18</a:t>
             </a:r>
           </a:p>
         </p:txBody>
@@ -3872,7 +4232,7 @@
           <a:lstStyle/>
           <a:p>
             <a:r>
-              <a:t>4. ImplicitRDP: An End-to-End Visual-Force Diffusion Policy with Structural Slow-Fa</a:t>
+              <a:t>4. Decoupled Q-Chunking</a:t>
             </a:r>
           </a:p>
         </p:txBody>
@@ -3893,25 +4253,58 @@
           <a:lstStyle/>
           <a:p>
             <a:r>
-              <a:t>Multi-modal policy framework combining vision and force sensing for robotic agents, advancing embodied AI manipulation capabilities.</a:t>
-            </a:r>
-          </a:p>
-          <a:p>
-            <a:pPr/>
-          </a:p>
-          <a:p>
-            <a:pPr/>
-            <a:r>
-              <a:t>📎 arXiv • Wendi Chen, Han Xue, Yi Wang</a:t>
-            </a:r>
-          </a:p>
-          <a:p>
-            <a:pPr/>
-          </a:p>
-          <a:p>
-            <a:pPr/>
-            <a:r>
-              <a:t>🔗 https://arxiv.org/abs/2512.10946v1</a:t>
+              <a:t>New TD learning method addressing bootstrapping bias in RL agents, improving</a:t>
+            </a:r>
+          </a:p>
+          <a:p>
+            <a:r>
+              <a:t>agent training efficiency and stability for autonomous decision-making.</a:t>
+            </a:r>
+          </a:p>
+          <a:p>
+            <a:pPr/>
+          </a:p>
+          <a:p>
+            <a:pPr/>
+            <a:r>
+              <a:t>Source: arXiv • Qiyang Li, Seohong Park, Sergey Levine</a:t>
+            </a:r>
+          </a:p>
+          <a:p>
+            <a:pPr/>
+            <a:r>
+              <a:t>Link: https://arxiv.org/abs/2512.10926v1</a:t>
+            </a:r>
+          </a:p>
+        </p:txBody>
+      </p:sp>
+      <p:sp>
+        <p:nvSpPr>
+          <p:cNvPr id="4" name="TextBox 3"/>
+          <p:cNvSpPr txBox="1"/>
+          <p:nvPr/>
+        </p:nvSpPr>
+        <p:spPr>
+          <a:xfrm>
+            <a:off x="457200" y="6400800"/>
+            <a:ext cx="7315200" cy="274320"/>
+          </a:xfrm>
+          <a:prstGeom prst="rect">
+            <a:avLst/>
+          </a:prstGeom>
+          <a:noFill/>
+        </p:spPr>
+        <p:txBody>
+          <a:bodyPr wrap="none">
+            <a:spAutoFit/>
+          </a:bodyPr>
+          <a:lstStyle/>
+          <a:p>
+            <a:pPr algn="ctr">
+              <a:defRPr sz="1000"/>
+            </a:pPr>
+            <a:r>
+              <a:t>Slide 19</a:t>
             </a:r>
           </a:p>
         </p:txBody>
@@ -3971,22 +4364,73 @@
           <a:lstStyle/>
           <a:p>
             <a:r>
-              <a:t>This week saw significant advances in interactive reasoning with training-free methods for asynchronous thinking, while OpenAI quietly rolled out 'skills' functionality and released GPT-5.2. The gap between impressive agent capabilities on benchmarks and real-world economic impact emerged as a key discussion point, highlighted by Ilya Sutskever's observations, while practical demonstrations like the autonomous Stanford network penetration test showcased the maturing state of autonomous agent planning and tool use.</a:t>
-            </a:r>
-          </a:p>
-          <a:p>
-            <a:pPr/>
-          </a:p>
-          <a:p>
-            <a:pPr/>
-            <a:r>
-              <a:t>📊 Curated from research papers, industry news, and community discussions</a:t>
-            </a:r>
-          </a:p>
-          <a:p>
-            <a:pPr/>
-            <a:r>
-              <a:t>🗓️  2025-12-14</a:t>
+              <a:t>This week saw major advances in interactive reasoning with training-free asynchronous</a:t>
+            </a:r>
+          </a:p>
+          <a:p>
+            <a:r>
+              <a:t>thinking capabilities and OpenAI's introduction of 'skills' for structured tool use in</a:t>
+            </a:r>
+          </a:p>
+          <a:p>
+            <a:r>
+              <a:t>ChatGPT. Real-world agent deployments demonstrated autonomous cybersecurity operations and</a:t>
+            </a:r>
+          </a:p>
+          <a:p>
+            <a:r>
+              <a:t>military applications, while the community grappled with the growing gap between benchmark</a:t>
+            </a:r>
+          </a:p>
+          <a:p>
+            <a:r>
+              <a:t>performance and economic impact of agentic systems.</a:t>
+            </a:r>
+          </a:p>
+          <a:p>
+            <a:pPr/>
+          </a:p>
+          <a:p>
+            <a:pPr/>
+            <a:r>
+              <a:t>Curated from arXiv, Hacker News, and Reddit</a:t>
+            </a:r>
+          </a:p>
+          <a:p>
+            <a:pPr/>
+            <a:r>
+              <a:t>Generated: 2025-12-14</a:t>
+            </a:r>
+          </a:p>
+        </p:txBody>
+      </p:sp>
+      <p:sp>
+        <p:nvSpPr>
+          <p:cNvPr id="4" name="TextBox 3"/>
+          <p:cNvSpPr txBox="1"/>
+          <p:nvPr/>
+        </p:nvSpPr>
+        <p:spPr>
+          <a:xfrm>
+            <a:off x="457200" y="6400800"/>
+            <a:ext cx="7315200" cy="274320"/>
+          </a:xfrm>
+          <a:prstGeom prst="rect">
+            <a:avLst/>
+          </a:prstGeom>
+          <a:noFill/>
+        </p:spPr>
+        <p:txBody>
+          <a:bodyPr wrap="none">
+            <a:spAutoFit/>
+          </a:bodyPr>
+          <a:lstStyle/>
+          <a:p>
+            <a:pPr algn="ctr">
+              <a:defRPr sz="1000"/>
+            </a:pPr>
+            <a:r>
+              <a:t>Slide 2</a:t>
             </a:r>
           </a:p>
         </p:txBody>
@@ -4049,6 +4493,46 @@
               <a:t>4 key updates</a:t>
             </a:r>
           </a:p>
+          <a:p>
+            <a:pPr/>
+          </a:p>
+          <a:p>
+            <a:pPr/>
+            <a:r>
+              <a:t>Swipe to explore →</a:t>
+            </a:r>
+          </a:p>
+        </p:txBody>
+      </p:sp>
+      <p:sp>
+        <p:nvSpPr>
+          <p:cNvPr id="4" name="TextBox 3"/>
+          <p:cNvSpPr txBox="1"/>
+          <p:nvPr/>
+        </p:nvSpPr>
+        <p:spPr>
+          <a:xfrm>
+            <a:off x="457200" y="6400800"/>
+            <a:ext cx="7315200" cy="274320"/>
+          </a:xfrm>
+          <a:prstGeom prst="rect">
+            <a:avLst/>
+          </a:prstGeom>
+          <a:noFill/>
+        </p:spPr>
+        <p:txBody>
+          <a:bodyPr wrap="none">
+            <a:spAutoFit/>
+          </a:bodyPr>
+          <a:lstStyle/>
+          <a:p>
+            <a:pPr algn="ctr">
+              <a:defRPr sz="1000"/>
+            </a:pPr>
+            <a:r>
+              <a:t>Slide 20</a:t>
+            </a:r>
+          </a:p>
         </p:txBody>
       </p:sp>
     </p:spTree>
@@ -4085,7 +4569,7 @@
           <a:lstStyle/>
           <a:p>
             <a:r>
-              <a:t>1. Ilya Sutskever is puzzled by the gap between AI benchmarks and the economic impa</a:t>
+              <a:t>1. Ilya Sutskever is puzzled by the gap between AI benchmarks and the ...</a:t>
             </a:r>
           </a:p>
         </p:txBody>
@@ -4106,25 +4590,63 @@
           <a:lstStyle/>
           <a:p>
             <a:r>
-              <a:t>Key industry figure questions the disconnect between agent capabilities on benchmarks versus real-world economic deployment and value creation.</a:t>
-            </a:r>
-          </a:p>
-          <a:p>
-            <a:pPr/>
-          </a:p>
-          <a:p>
-            <a:pPr/>
-            <a:r>
-              <a:t>📎 r/MachineLearning • 288 upvotes • 121 comments</a:t>
-            </a:r>
-          </a:p>
-          <a:p>
-            <a:pPr/>
-          </a:p>
-          <a:p>
-            <a:pPr/>
-            <a:r>
-              <a:t>🔗 https://reddit.com/r/MachineLearning/comments/1pm2zsb/ilya_s</a:t>
+              <a:t>Critical discussion on the disconnect between agent performance on benchmarks</a:t>
+            </a:r>
+          </a:p>
+          <a:p>
+            <a:r>
+              <a:t>versus real-world deployment value, questioning evaluation methodologies for</a:t>
+            </a:r>
+          </a:p>
+          <a:p>
+            <a:r>
+              <a:t>agentic systems.</a:t>
+            </a:r>
+          </a:p>
+          <a:p>
+            <a:pPr/>
+          </a:p>
+          <a:p>
+            <a:pPr/>
+            <a:r>
+              <a:t>Source: r/MachineLearning • 294 upvotes • 122 comments</a:t>
+            </a:r>
+          </a:p>
+          <a:p>
+            <a:pPr/>
+            <a:r>
+              <a:t>Link: https://reddit.com/r/MachineLearning/comments/1...</a:t>
+            </a:r>
+          </a:p>
+        </p:txBody>
+      </p:sp>
+      <p:sp>
+        <p:nvSpPr>
+          <p:cNvPr id="4" name="TextBox 3"/>
+          <p:cNvSpPr txBox="1"/>
+          <p:nvPr/>
+        </p:nvSpPr>
+        <p:spPr>
+          <a:xfrm>
+            <a:off x="457200" y="6400800"/>
+            <a:ext cx="7315200" cy="274320"/>
+          </a:xfrm>
+          <a:prstGeom prst="rect">
+            <a:avLst/>
+          </a:prstGeom>
+          <a:noFill/>
+        </p:spPr>
+        <p:txBody>
+          <a:bodyPr wrap="none">
+            <a:spAutoFit/>
+          </a:bodyPr>
+          <a:lstStyle/>
+          <a:p>
+            <a:pPr algn="ctr">
+              <a:defRPr sz="1000"/>
+            </a:pPr>
+            <a:r>
+              <a:t>Slide 21</a:t>
             </a:r>
           </a:p>
         </p:txBody>
@@ -4184,25 +4706,58 @@
           <a:lstStyle/>
           <a:p>
             <a:r>
-              <a:t>Discussion of challenges facing the leading agentic AI company, with implications for the future trajectory of autonomous agent development and commercialization.</a:t>
-            </a:r>
-          </a:p>
-          <a:p>
-            <a:pPr/>
-          </a:p>
-          <a:p>
-            <a:pPr/>
-            <a:r>
-              <a:t>📎 r/artificial • 203 upvotes • 121 comments</a:t>
-            </a:r>
-          </a:p>
-          <a:p>
-            <a:pPr/>
-          </a:p>
-          <a:p>
-            <a:pPr/>
-            <a:r>
-              <a:t>🔗 https://reddit.com/r/artificial/comments/1pj66p2/openai_is_i</a:t>
+              <a:t>Analysis of challenges facing the leading agentic AI company, with implications</a:t>
+            </a:r>
+          </a:p>
+          <a:p>
+            <a:r>
+              <a:t>for the broader agent development ecosystem and competitive landscape.</a:t>
+            </a:r>
+          </a:p>
+          <a:p>
+            <a:pPr/>
+          </a:p>
+          <a:p>
+            <a:pPr/>
+            <a:r>
+              <a:t>Source: r/artificial • 203 upvotes • 121 comments</a:t>
+            </a:r>
+          </a:p>
+          <a:p>
+            <a:pPr/>
+            <a:r>
+              <a:t>Link: https://reddit.com/r/artificial/comments/1pj66p...</a:t>
+            </a:r>
+          </a:p>
+        </p:txBody>
+      </p:sp>
+      <p:sp>
+        <p:nvSpPr>
+          <p:cNvPr id="4" name="TextBox 3"/>
+          <p:cNvSpPr txBox="1"/>
+          <p:nvPr/>
+        </p:nvSpPr>
+        <p:spPr>
+          <a:xfrm>
+            <a:off x="457200" y="6400800"/>
+            <a:ext cx="7315200" cy="274320"/>
+          </a:xfrm>
+          <a:prstGeom prst="rect">
+            <a:avLst/>
+          </a:prstGeom>
+          <a:noFill/>
+        </p:spPr>
+        <p:txBody>
+          <a:bodyPr wrap="none">
+            <a:spAutoFit/>
+          </a:bodyPr>
+          <a:lstStyle/>
+          <a:p>
+            <a:pPr algn="ctr">
+              <a:defRPr sz="1000"/>
+            </a:pPr>
+            <a:r>
+              <a:t>Slide 22</a:t>
             </a:r>
           </a:p>
         </p:txBody>
@@ -4241,7 +4796,7 @@
           <a:lstStyle/>
           <a:p>
             <a:r>
-              <a:t>3. LLMs can understand Base64 encoded instructions</a:t>
+              <a:t>3. Something Ominous Is Happening in the AI Economy</a:t>
             </a:r>
           </a:p>
         </p:txBody>
@@ -4262,25 +4817,58 @@
           <a:lstStyle/>
           <a:p>
             <a:r>
-              <a:t>Reveals emergent capability in LLMs with implications for agent security, jailbreaking resistance, and instruction-following robustness in autonomous systems.</a:t>
-            </a:r>
-          </a:p>
-          <a:p>
-            <a:pPr/>
-          </a:p>
-          <a:p>
-            <a:pPr/>
-            <a:r>
-              <a:t>📎 r/artificial • 169 upvotes • 71 comments</a:t>
-            </a:r>
-          </a:p>
-          <a:p>
-            <a:pPr/>
-          </a:p>
-          <a:p>
-            <a:pPr/>
-            <a:r>
-              <a:t>🔗 https://reddit.com/r/artificial/comments/1pioxt4/llms_can_un</a:t>
+              <a:t>Community concerns about sustainability and economics of deploying agentic AI</a:t>
+            </a:r>
+          </a:p>
+          <a:p>
+            <a:r>
+              <a:t>systems at scale, addressing viability of autonomous agent business models.</a:t>
+            </a:r>
+          </a:p>
+          <a:p>
+            <a:pPr/>
+          </a:p>
+          <a:p>
+            <a:pPr/>
+            <a:r>
+              <a:t>Source: r/artificial • 159 upvotes • 70 comments</a:t>
+            </a:r>
+          </a:p>
+          <a:p>
+            <a:pPr/>
+            <a:r>
+              <a:t>Link: https://reddit.com/r/artificial/comments/1pk6av...</a:t>
+            </a:r>
+          </a:p>
+        </p:txBody>
+      </p:sp>
+      <p:sp>
+        <p:nvSpPr>
+          <p:cNvPr id="4" name="TextBox 3"/>
+          <p:cNvSpPr txBox="1"/>
+          <p:nvPr/>
+        </p:nvSpPr>
+        <p:spPr>
+          <a:xfrm>
+            <a:off x="457200" y="6400800"/>
+            <a:ext cx="7315200" cy="274320"/>
+          </a:xfrm>
+          <a:prstGeom prst="rect">
+            <a:avLst/>
+          </a:prstGeom>
+          <a:noFill/>
+        </p:spPr>
+        <p:txBody>
+          <a:bodyPr wrap="none">
+            <a:spAutoFit/>
+          </a:bodyPr>
+          <a:lstStyle/>
+          <a:p>
+            <a:pPr algn="ctr">
+              <a:defRPr sz="1000"/>
+            </a:pPr>
+            <a:r>
+              <a:t>Slide 23</a:t>
             </a:r>
           </a:p>
         </p:txBody>
@@ -4319,7 +4907,7 @@
           <a:lstStyle/>
           <a:p>
             <a:r>
-              <a:t>4. Something Ominous Is Happening in the AI Economy</a:t>
+              <a:t>4. Mistral AI drops 3x as many LLMs in a single week as OpenAI did in ...</a:t>
             </a:r>
           </a:p>
         </p:txBody>
@@ -4340,25 +4928,63 @@
           <a:lstStyle/>
           <a:p>
             <a:r>
-              <a:t>Analysis of economic tensions in AI development that may affect funding and direction of agentic AI research and commercial deployment.</a:t>
-            </a:r>
-          </a:p>
-          <a:p>
-            <a:pPr/>
-          </a:p>
-          <a:p>
-            <a:pPr/>
-            <a:r>
-              <a:t>📎 r/artificial • 154 upvotes • 70 comments</a:t>
-            </a:r>
-          </a:p>
-          <a:p>
-            <a:pPr/>
-          </a:p>
-          <a:p>
-            <a:pPr/>
-            <a:r>
-              <a:t>🔗 https://reddit.com/r/artificial/comments/1pk6avk/something_o</a:t>
+              <a:t>Discussion on rapid model release pace and its implications for agent framework</a:t>
+            </a:r>
+          </a:p>
+          <a:p>
+            <a:r>
+              <a:t>development, highlighting tension between iteration speed and stability in</a:t>
+            </a:r>
+          </a:p>
+          <a:p>
+            <a:r>
+              <a:t>agentic systems.</a:t>
+            </a:r>
+          </a:p>
+          <a:p>
+            <a:pPr/>
+          </a:p>
+          <a:p>
+            <a:pPr/>
+            <a:r>
+              <a:t>Source: r/LocalLLaMA • 842 upvotes • 111 comments</a:t>
+            </a:r>
+          </a:p>
+          <a:p>
+            <a:pPr/>
+            <a:r>
+              <a:t>Link: https://reddit.com/r/LocalLLaMA/comments/1pj8kb...</a:t>
+            </a:r>
+          </a:p>
+        </p:txBody>
+      </p:sp>
+      <p:sp>
+        <p:nvSpPr>
+          <p:cNvPr id="4" name="TextBox 3"/>
+          <p:cNvSpPr txBox="1"/>
+          <p:nvPr/>
+        </p:nvSpPr>
+        <p:spPr>
+          <a:xfrm>
+            <a:off x="457200" y="6400800"/>
+            <a:ext cx="7315200" cy="274320"/>
+          </a:xfrm>
+          <a:prstGeom prst="rect">
+            <a:avLst/>
+          </a:prstGeom>
+          <a:noFill/>
+        </p:spPr>
+        <p:txBody>
+          <a:bodyPr wrap="none">
+            <a:spAutoFit/>
+          </a:bodyPr>
+          <a:lstStyle/>
+          <a:p>
+            <a:pPr algn="ctr">
+              <a:defRPr sz="1000"/>
+            </a:pPr>
+            <a:r>
+              <a:t>Slide 24</a:t>
             </a:r>
           </a:p>
         </p:txBody>
@@ -4397,7 +5023,7 @@
           <a:lstStyle/>
           <a:p>
             <a:r>
-              <a:t>Keep Learning 🚀</a:t>
+              <a:t>Stay Curious</a:t>
             </a:r>
           </a:p>
         </p:txBody>
@@ -4418,43 +5044,80 @@
           <a:lstStyle/>
           <a:p>
             <a:r>
-              <a:t>This digest was automatically generated</a:t>
-            </a:r>
-          </a:p>
-          <a:p>
-            <a:pPr/>
-          </a:p>
-          <a:p>
-            <a:pPr/>
-            <a:r>
-              <a:t>Sources:</a:t>
-            </a:r>
-          </a:p>
-          <a:p>
-            <a:pPr/>
-            <a:r>
-              <a:t>• arXiv research papers</a:t>
-            </a:r>
-          </a:p>
-          <a:p>
-            <a:pPr/>
-            <a:r>
-              <a:t>• Hacker News discussions</a:t>
-            </a:r>
-          </a:p>
-          <a:p>
-            <a:pPr/>
-            <a:r>
-              <a:t>• Reddit communities (r/MachineLearning, r/LocalLLaMA)</a:t>
-            </a:r>
-          </a:p>
-          <a:p>
-            <a:pPr/>
-          </a:p>
-          <a:p>
-            <a:pPr/>
-            <a:r>
-              <a:t>Next digest: December 21, 2025</a:t>
+              <a:t>Your weekly AI digest</a:t>
+            </a:r>
+          </a:p>
+          <a:p>
+            <a:pPr/>
+            <a:r>
+              <a:t>Automatically curated every Sunday</a:t>
+            </a:r>
+          </a:p>
+          <a:p>
+            <a:pPr/>
+          </a:p>
+          <a:p>
+            <a:pPr/>
+            <a:r>
+              <a:t>Data Sources:</a:t>
+            </a:r>
+          </a:p>
+          <a:p>
+            <a:pPr/>
+            <a:r>
+              <a:t>  → arXiv Research Papers</a:t>
+            </a:r>
+          </a:p>
+          <a:p>
+            <a:pPr/>
+            <a:r>
+              <a:t>  → Hacker News</a:t>
+            </a:r>
+          </a:p>
+          <a:p>
+            <a:pPr/>
+            <a:r>
+              <a:t>  → Reddit ML Communities</a:t>
+            </a:r>
+          </a:p>
+          <a:p>
+            <a:pPr/>
+          </a:p>
+          <a:p>
+            <a:pPr/>
+            <a:r>
+              <a:t>Next edition: December 21, 2025</a:t>
+            </a:r>
+          </a:p>
+        </p:txBody>
+      </p:sp>
+      <p:sp>
+        <p:nvSpPr>
+          <p:cNvPr id="4" name="TextBox 3"/>
+          <p:cNvSpPr txBox="1"/>
+          <p:nvPr/>
+        </p:nvSpPr>
+        <p:spPr>
+          <a:xfrm>
+            <a:off x="457200" y="6400800"/>
+            <a:ext cx="7315200" cy="274320"/>
+          </a:xfrm>
+          <a:prstGeom prst="rect">
+            <a:avLst/>
+          </a:prstGeom>
+          <a:noFill/>
+        </p:spPr>
+        <p:txBody>
+          <a:bodyPr wrap="none">
+            <a:spAutoFit/>
+          </a:bodyPr>
+          <a:lstStyle/>
+          <a:p>
+            <a:pPr algn="ctr">
+              <a:defRPr sz="1000"/>
+            </a:pPr>
+            <a:r>
+              <a:t>Slide 25</a:t>
             </a:r>
           </a:p>
         </p:txBody>
@@ -4517,6 +5180,46 @@
               <a:t>5 key updates</a:t>
             </a:r>
           </a:p>
+          <a:p>
+            <a:pPr/>
+          </a:p>
+          <a:p>
+            <a:pPr/>
+            <a:r>
+              <a:t>Swipe to explore →</a:t>
+            </a:r>
+          </a:p>
+        </p:txBody>
+      </p:sp>
+      <p:sp>
+        <p:nvSpPr>
+          <p:cNvPr id="4" name="TextBox 3"/>
+          <p:cNvSpPr txBox="1"/>
+          <p:nvPr/>
+        </p:nvSpPr>
+        <p:spPr>
+          <a:xfrm>
+            <a:off x="457200" y="6400800"/>
+            <a:ext cx="7315200" cy="274320"/>
+          </a:xfrm>
+          <a:prstGeom prst="rect">
+            <a:avLst/>
+          </a:prstGeom>
+          <a:noFill/>
+        </p:spPr>
+        <p:txBody>
+          <a:bodyPr wrap="none">
+            <a:spAutoFit/>
+          </a:bodyPr>
+          <a:lstStyle/>
+          <a:p>
+            <a:pPr algn="ctr">
+              <a:defRPr sz="1000"/>
+            </a:pPr>
+            <a:r>
+              <a:t>Slide 3</a:t>
+            </a:r>
+          </a:p>
         </p:txBody>
       </p:sp>
     </p:spTree>
@@ -4574,25 +5277,63 @@
           <a:lstStyle/>
           <a:p>
             <a:r>
-              <a:t>Enables LLMs to think asynchronously while remaining interactive, allowing users to interrupt and redirect reasoning processes without retraining.</a:t>
-            </a:r>
-          </a:p>
-          <a:p>
-            <a:pPr/>
-          </a:p>
-          <a:p>
-            <a:pPr/>
-            <a:r>
-              <a:t>📎 arXiv • George Yakushev, Nataliia Babina, Masoud Vahid Dastgerdi</a:t>
-            </a:r>
-          </a:p>
-          <a:p>
-            <a:pPr/>
-          </a:p>
-          <a:p>
-            <a:pPr/>
-            <a:r>
-              <a:t>🔗 https://arxiv.org/abs/2512.10931v1</a:t>
+              <a:t>Enables LLMs to perform reasoning asynchronously without training, allowing</a:t>
+            </a:r>
+          </a:p>
+          <a:p>
+            <a:r>
+              <a:t>interactive responses while maintaining thinking capabilities—addressing a key</a:t>
+            </a:r>
+          </a:p>
+          <a:p>
+            <a:r>
+              <a:t>limitation of current reasoning models.</a:t>
+            </a:r>
+          </a:p>
+          <a:p>
+            <a:pPr/>
+          </a:p>
+          <a:p>
+            <a:pPr/>
+            <a:r>
+              <a:t>Source: arXiv • George Yakushev, Nataliia Babina, Masoud Vahid Da...</a:t>
+            </a:r>
+          </a:p>
+          <a:p>
+            <a:pPr/>
+            <a:r>
+              <a:t>Link: https://arxiv.org/abs/2512.10931v1</a:t>
+            </a:r>
+          </a:p>
+        </p:txBody>
+      </p:sp>
+      <p:sp>
+        <p:nvSpPr>
+          <p:cNvPr id="4" name="TextBox 3"/>
+          <p:cNvSpPr txBox="1"/>
+          <p:nvPr/>
+        </p:nvSpPr>
+        <p:spPr>
+          <a:xfrm>
+            <a:off x="457200" y="6400800"/>
+            <a:ext cx="7315200" cy="274320"/>
+          </a:xfrm>
+          <a:prstGeom prst="rect">
+            <a:avLst/>
+          </a:prstGeom>
+          <a:noFill/>
+        </p:spPr>
+        <p:txBody>
+          <a:bodyPr wrap="none">
+            <a:spAutoFit/>
+          </a:bodyPr>
+          <a:lstStyle/>
+          <a:p>
+            <a:pPr algn="ctr">
+              <a:defRPr sz="1000"/>
+            </a:pPr>
+            <a:r>
+              <a:t>Slide 4</a:t>
             </a:r>
           </a:p>
         </p:txBody>
@@ -4631,7 +5372,7 @@
           <a:lstStyle/>
           <a:p>
             <a:r>
-              <a:t>2. On Decision-Making Agents and Higher-Order Causal Processes</a:t>
+              <a:t>2. CompanionCast: A Multi-Agent Conversational AI Framework with Spati...</a:t>
             </a:r>
           </a:p>
         </p:txBody>
@@ -4652,25 +5393,63 @@
           <a:lstStyle/>
           <a:p>
             <a:r>
-              <a:t>Establishes formal mathematical correspondence between POMDP agents and higher-order causal processes, providing theoretical foundations for agent decision-making.</a:t>
-            </a:r>
-          </a:p>
-          <a:p>
-            <a:pPr/>
-          </a:p>
-          <a:p>
-            <a:pPr/>
-            <a:r>
-              <a:t>📎 arXiv • Matt Wilson</a:t>
-            </a:r>
-          </a:p>
-          <a:p>
-            <a:pPr/>
-          </a:p>
-          <a:p>
-            <a:pPr/>
-            <a:r>
-              <a:t>🔗 https://arxiv.org/abs/2512.10937v1</a:t>
+              <a:t>Novel multi-agent system that recreates social presence through coordinated</a:t>
+            </a:r>
+          </a:p>
+          <a:p>
+            <a:r>
+              <a:t>conversational AI agents with spatial audio, demonstrating practical</a:t>
+            </a:r>
+          </a:p>
+          <a:p>
+            <a:r>
+              <a:t>applications of agent coordination for human experience.</a:t>
+            </a:r>
+          </a:p>
+          <a:p>
+            <a:pPr/>
+          </a:p>
+          <a:p>
+            <a:pPr/>
+            <a:r>
+              <a:t>Source: arXiv • Yiyang Wang, Chen Chen, Tica Lin</a:t>
+            </a:r>
+          </a:p>
+          <a:p>
+            <a:pPr/>
+            <a:r>
+              <a:t>Link: https://arxiv.org/abs/2512.10918v1</a:t>
+            </a:r>
+          </a:p>
+        </p:txBody>
+      </p:sp>
+      <p:sp>
+        <p:nvSpPr>
+          <p:cNvPr id="4" name="TextBox 3"/>
+          <p:cNvSpPr txBox="1"/>
+          <p:nvPr/>
+        </p:nvSpPr>
+        <p:spPr>
+          <a:xfrm>
+            <a:off x="457200" y="6400800"/>
+            <a:ext cx="7315200" cy="274320"/>
+          </a:xfrm>
+          <a:prstGeom prst="rect">
+            <a:avLst/>
+          </a:prstGeom>
+          <a:noFill/>
+        </p:spPr>
+        <p:txBody>
+          <a:bodyPr wrap="none">
+            <a:spAutoFit/>
+          </a:bodyPr>
+          <a:lstStyle/>
+          <a:p>
+            <a:pPr algn="ctr">
+              <a:defRPr sz="1000"/>
+            </a:pPr>
+            <a:r>
+              <a:t>Slide 5</a:t>
             </a:r>
           </a:p>
         </p:txBody>
@@ -4709,7 +5488,7 @@
           <a:lstStyle/>
           <a:p>
             <a:r>
-              <a:t>3. CompanionCast: A Multi-Agent Conversational AI Framework with Spatial Audio for </a:t>
+              <a:t>3. On Decision-Making Agents and Higher-Order Causal Processes</a:t>
             </a:r>
           </a:p>
         </p:txBody>
@@ -4730,25 +5509,63 @@
           <a:lstStyle/>
           <a:p>
             <a:r>
-              <a:t>Multi-agent conversational system that recreates social presence for media consumption, demonstrating practical applications of agent coordination for user experience.</a:t>
-            </a:r>
-          </a:p>
-          <a:p>
-            <a:pPr/>
-          </a:p>
-          <a:p>
-            <a:pPr/>
-            <a:r>
-              <a:t>📎 arXiv • Yiyang Wang, Chen Chen, Tica Lin</a:t>
-            </a:r>
-          </a:p>
-          <a:p>
-            <a:pPr/>
-          </a:p>
-          <a:p>
-            <a:pPr/>
-            <a:r>
-              <a:t>🔗 https://arxiv.org/abs/2512.10918v1</a:t>
+              <a:t>Establishes theoretical correspondence between POMDP agents and higher-order</a:t>
+            </a:r>
+          </a:p>
+          <a:p>
+            <a:r>
+              <a:t>quantum causal processes, providing foundational mathematical framework for</a:t>
+            </a:r>
+          </a:p>
+          <a:p>
+            <a:r>
+              <a:t>understanding agent decision-making.</a:t>
+            </a:r>
+          </a:p>
+          <a:p>
+            <a:pPr/>
+          </a:p>
+          <a:p>
+            <a:pPr/>
+            <a:r>
+              <a:t>Source: arXiv • Matt Wilson</a:t>
+            </a:r>
+          </a:p>
+          <a:p>
+            <a:pPr/>
+            <a:r>
+              <a:t>Link: https://arxiv.org/abs/2512.10937v1</a:t>
+            </a:r>
+          </a:p>
+        </p:txBody>
+      </p:sp>
+      <p:sp>
+        <p:nvSpPr>
+          <p:cNvPr id="4" name="TextBox 3"/>
+          <p:cNvSpPr txBox="1"/>
+          <p:nvPr/>
+        </p:nvSpPr>
+        <p:spPr>
+          <a:xfrm>
+            <a:off x="457200" y="6400800"/>
+            <a:ext cx="7315200" cy="274320"/>
+          </a:xfrm>
+          <a:prstGeom prst="rect">
+            <a:avLst/>
+          </a:prstGeom>
+          <a:noFill/>
+        </p:spPr>
+        <p:txBody>
+          <a:bodyPr wrap="none">
+            <a:spAutoFit/>
+          </a:bodyPr>
+          <a:lstStyle/>
+          <a:p>
+            <a:pPr algn="ctr">
+              <a:defRPr sz="1000"/>
+            </a:pPr>
+            <a:r>
+              <a:t>Slide 6</a:t>
             </a:r>
           </a:p>
         </p:txBody>
@@ -4787,7 +5604,7 @@
           <a:lstStyle/>
           <a:p>
             <a:r>
-              <a:t>4. Curriculum-Based Reinforcement Learning for Autonomous UAV Navigation in Unknown</a:t>
+              <a:t>4. Curriculum-Based Reinforcement Learning for Autonomous UAV Navigati...</a:t>
             </a:r>
           </a:p>
         </p:txBody>
@@ -4808,25 +5625,63 @@
           <a:lstStyle/>
           <a:p>
             <a:r>
-              <a:t>Applies curriculum-based RL for autonomous navigation in highly constrained environments, advancing agent planning and perception in challenging real-world scenarios.</a:t>
-            </a:r>
-          </a:p>
-          <a:p>
-            <a:pPr/>
-          </a:p>
-          <a:p>
-            <a:pPr/>
-            <a:r>
-              <a:t>📎 arXiv • Zamirddine Mari, Jérôme Pasquet, Julien Seinturier</a:t>
-            </a:r>
-          </a:p>
-          <a:p>
-            <a:pPr/>
-          </a:p>
-          <a:p>
-            <a:pPr/>
-            <a:r>
-              <a:t>🔗 https://arxiv.org/abs/2512.10934v1</a:t>
+              <a:t>Demonstrates curriculum-based RL approach for autonomous navigation in highly</a:t>
+            </a:r>
+          </a:p>
+          <a:p>
+            <a:r>
+              <a:t>constrained environments, showcasing advanced planning and reasoning in</a:t>
+            </a:r>
+          </a:p>
+          <a:p>
+            <a:r>
+              <a:t>challenging real-world scenarios.</a:t>
+            </a:r>
+          </a:p>
+          <a:p>
+            <a:pPr/>
+          </a:p>
+          <a:p>
+            <a:pPr/>
+            <a:r>
+              <a:t>Source: arXiv • Zamirddine Mari, Jérôme Pasquet, Julien Seinturier</a:t>
+            </a:r>
+          </a:p>
+          <a:p>
+            <a:pPr/>
+            <a:r>
+              <a:t>Link: https://arxiv.org/abs/2512.10934v1</a:t>
+            </a:r>
+          </a:p>
+        </p:txBody>
+      </p:sp>
+      <p:sp>
+        <p:nvSpPr>
+          <p:cNvPr id="4" name="TextBox 3"/>
+          <p:cNvSpPr txBox="1"/>
+          <p:nvPr/>
+        </p:nvSpPr>
+        <p:spPr>
+          <a:xfrm>
+            <a:off x="457200" y="6400800"/>
+            <a:ext cx="7315200" cy="274320"/>
+          </a:xfrm>
+          <a:prstGeom prst="rect">
+            <a:avLst/>
+          </a:prstGeom>
+          <a:noFill/>
+        </p:spPr>
+        <p:txBody>
+          <a:bodyPr wrap="none">
+            <a:spAutoFit/>
+          </a:bodyPr>
+          <a:lstStyle/>
+          <a:p>
+            <a:pPr algn="ctr">
+              <a:defRPr sz="1000"/>
+            </a:pPr>
+            <a:r>
+              <a:t>Slide 7</a:t>
             </a:r>
           </a:p>
         </p:txBody>
@@ -4865,7 +5720,7 @@
           <a:lstStyle/>
           <a:p>
             <a:r>
-              <a:t>5. Replace, Don't Expand: Mitigating Context Dilution in Multi-Hop RAG via Fixed-Bu</a:t>
+              <a:t>5. Replace, Don't Expand: Mitigating Context Dilution in Multi-Hop RAG...</a:t>
             </a:r>
           </a:p>
         </p:txBody>
@@ -4886,25 +5741,63 @@
           <a:lstStyle/>
           <a:p>
             <a:r>
-              <a:t>Introduces fixed-budget evidence assembly strategy for multi-hop RAG systems, improving agent tool use and retrieval planning without expanding context windows.</a:t>
-            </a:r>
-          </a:p>
-          <a:p>
-            <a:pPr/>
-          </a:p>
-          <a:p>
-            <a:pPr/>
-            <a:r>
-              <a:t>📎 arXiv • Moshe Lahmy, Roi Yozevitch</a:t>
-            </a:r>
-          </a:p>
-          <a:p>
-            <a:pPr/>
-          </a:p>
-          <a:p>
-            <a:pPr/>
-            <a:r>
-              <a:t>🔗 https://arxiv.org/abs/2512.10787v1</a:t>
+              <a:t>Addresses critical multi-hop reasoning failures in RAG systems by introducing</a:t>
+            </a:r>
+          </a:p>
+          <a:p>
+            <a:r>
+              <a:t>fixed-budget evidence replacement strategy, improving agent tool use and</a:t>
+            </a:r>
+          </a:p>
+          <a:p>
+            <a:r>
+              <a:t>reasoning efficiency.</a:t>
+            </a:r>
+          </a:p>
+          <a:p>
+            <a:pPr/>
+          </a:p>
+          <a:p>
+            <a:pPr/>
+            <a:r>
+              <a:t>Source: arXiv • Moshe Lahmy, Roi Yozevitch</a:t>
+            </a:r>
+          </a:p>
+          <a:p>
+            <a:pPr/>
+            <a:r>
+              <a:t>Link: https://arxiv.org/abs/2512.10787v1</a:t>
+            </a:r>
+          </a:p>
+        </p:txBody>
+      </p:sp>
+      <p:sp>
+        <p:nvSpPr>
+          <p:cNvPr id="4" name="TextBox 3"/>
+          <p:cNvSpPr txBox="1"/>
+          <p:nvPr/>
+        </p:nvSpPr>
+        <p:spPr>
+          <a:xfrm>
+            <a:off x="457200" y="6400800"/>
+            <a:ext cx="7315200" cy="274320"/>
+          </a:xfrm>
+          <a:prstGeom prst="rect">
+            <a:avLst/>
+          </a:prstGeom>
+          <a:noFill/>
+        </p:spPr>
+        <p:txBody>
+          <a:bodyPr wrap="none">
+            <a:spAutoFit/>
+          </a:bodyPr>
+          <a:lstStyle/>
+          <a:p>
+            <a:pPr algn="ctr">
+              <a:defRPr sz="1000"/>
+            </a:pPr>
+            <a:r>
+              <a:t>Slide 8</a:t>
             </a:r>
           </a:p>
         </p:txBody>
@@ -4965,6 +5858,46 @@
           <a:p>
             <a:r>
               <a:t>5 key updates</a:t>
+            </a:r>
+          </a:p>
+          <a:p>
+            <a:pPr/>
+          </a:p>
+          <a:p>
+            <a:pPr/>
+            <a:r>
+              <a:t>Swipe to explore →</a:t>
+            </a:r>
+          </a:p>
+        </p:txBody>
+      </p:sp>
+      <p:sp>
+        <p:nvSpPr>
+          <p:cNvPr id="4" name="TextBox 3"/>
+          <p:cNvSpPr txBox="1"/>
+          <p:nvPr/>
+        </p:nvSpPr>
+        <p:spPr>
+          <a:xfrm>
+            <a:off x="457200" y="6400800"/>
+            <a:ext cx="7315200" cy="274320"/>
+          </a:xfrm>
+          <a:prstGeom prst="rect">
+            <a:avLst/>
+          </a:prstGeom>
+          <a:noFill/>
+        </p:spPr>
+        <p:txBody>
+          <a:bodyPr wrap="none">
+            <a:spAutoFit/>
+          </a:bodyPr>
+          <a:lstStyle/>
+          <a:p>
+            <a:pPr algn="ctr">
+              <a:defRPr sz="1000"/>
+            </a:pPr>
+            <a:r>
+              <a:t>Slide 9</a:t>
             </a:r>
           </a:p>
         </p:txBody>

</xml_diff>